<commit_message>
CONSAÚDE: planilha de vícios identificados no formato da planilha-modelo
28 vícios na aba principal (tema, vício, referência, criticidade em
branco para o advogado, comentários) e 7 pontos na aba de reservas.
Corrige no deck a citação das obrigações do Poder Concedente para a
cláusula 13.1, XV.

Co-Authored-By: Claude Opus 5.5 <noreply@anthropic.com>
Claude-Session: https://claude.ai/code/session_01TrfDHY9D3MKaQfyrVNihp9
</commit_message>
<xml_diff>
--- a/concessoes/consaude-conc-2026/output/pontos-de-atencao-2026-10-08.pptx
+++ b/concessoes/consaude-conc-2026/output/pontos-de-atencao-2026-10-08.pptx
@@ -129,18 +129,18 @@
   <p:extLst>
     <p:ext uri="{521415D9-36F7-43E2-AB2F-B90AF26B5E84}">
       <p14:sectionLst xmlns:p14="http://schemas.microsoft.com/office/powerpoint/2010/main">
-        <p14:section name="Capa" id="{42bdda5d-e6d5-befd-1041-2934820b6fbc}">
+        <p14:section name="Capa" id="{6c319b7f-c809-7768-218b-ccf9feb7074d}">
           <p14:sldIdLst>
             <p14:sldId id="256"/>
           </p14:sldIdLst>
         </p14:section>
-        <p14:section name="Informações Gerais" id="{b046b6bd-3904-ac5f-80fb-170b636dcc49}">
+        <p14:section name="Informações Gerais" id="{77bc1f84-fcf0-fefc-e964-7d155c602d34}">
           <p14:sldIdLst>
             <p14:sldId id="257"/>
             <p14:sldId id="258"/>
           </p14:sldIdLst>
         </p14:section>
-        <p14:section name="Aspectos Jurídicos Estratégicos" id="{c3a0be50-702b-3f2b-0bc0-3d266f0b3033}">
+        <p14:section name="Aspectos Jurídicos Estratégicos" id="{01305890-6539-50fa-d98e-7ce2201c59ef}">
           <p14:sldIdLst>
             <p14:sldId id="259"/>
             <p14:sldId id="260"/>
@@ -160,14 +160,14 @@
             <p14:sldId id="274"/>
           </p14:sldIdLst>
         </p14:section>
-        <p14:section name="Pontos de atenção" id="{e892df6e-b0dc-ba4c-9a41-f423937c0054}">
+        <p14:section name="Pontos de atenção" id="{48464bc7-604a-6e65-16d6-5c46f594292c}">
           <p14:sldIdLst>
             <p14:sldId id="275"/>
             <p14:sldId id="276"/>
             <p14:sldId id="277"/>
           </p14:sldIdLst>
         </p14:section>
-        <p14:section name="Encerramento" id="{30873528-56c6-3905-d65c-baa59f9e3d4a}">
+        <p14:section name="Encerramento" id="{3ffab46e-434d-d53b-d010-f2c8b6bd68b9}">
           <p14:sldIdLst>
             <p14:sldId id="278"/>
           </p14:sldIdLst>
@@ -5063,7 +5063,7 @@
                   <a:schemeClr val="tx1"/>
                 </a:solidFill>
               </a:rPr>
-              <a:t> a cl. 13, XV, (ii) remete ao subitem 25.2, que trata de bens reversíveis.</a:t>
+              <a:t> a cl. 13.1, XV, (ii) remete ao subitem 25.2, que trata de bens reversíveis.</a:t>
             </a:r>
             <a:endParaRPr lang="en-US" sz="1300" dirty="0"/>
           </a:p>
@@ -5491,7 +5491,7 @@
                   <a:schemeClr val="tx1"/>
                 </a:solidFill>
               </a:rPr>
-              <a:t>corrigir a remissão da cl. 13, XV, (ii).</a:t>
+              <a:t>corrigir a remissão da cl. 13.1, XV, (ii).</a:t>
             </a:r>
             <a:endParaRPr lang="en-US" sz="1400" dirty="0"/>
           </a:p>
@@ -14780,7 +14780,7 @@
                           <a:ea typeface="Calibri" pitchFamily="34" charset="-122"/>
                           <a:cs typeface="Calibri" pitchFamily="34" charset="-120"/>
                         </a:rPr>
-                        <a:t>Contrato, 9.3, 13, XV, e 17.8</a:t>
+                        <a:t>Contrato, 9.3, 13.1, XV, e 17.8</a:t>
                       </a:r>
                       <a:endParaRPr lang="en-US" sz="1250" dirty="0">
                         <a:latin typeface="Calibri" charset="0"/>
@@ -20903,7 +20903,7 @@
                   <a:schemeClr val="tx1"/>
                 </a:solidFill>
               </a:rPr>
-              <a:t>O Poder Concedente entrega o Cadastro Inicial como condição da Ordem de Serviço (cl. 7.4.1) e deve assegurar as informações cadastrais e de consumo (cl. 13, XV). A Matriz de Riscos aloca ao Poder Concedente apenas as falhas do Cadastro Inicial (item 36). Não há nos autos convênio, termo de cooperação ou anuência da prestadora de água.</a:t>
+              <a:t>O Poder Concedente entrega o Cadastro Inicial como condição da Ordem de Serviço (cl. 7.4.1) e deve assegurar as informações cadastrais e de consumo (cl. 13.1, XV). A Matriz de Riscos aloca ao Poder Concedente apenas as falhas do Cadastro Inicial (item 36). Não há nos autos convênio, termo de cooperação ou anuência da prestadora de água.</a:t>
             </a:r>
             <a:endParaRPr lang="en-US" sz="1250" dirty="0"/>
           </a:p>
@@ -20950,7 +20950,7 @@
         <p:spPr>
           <a:xfrm>
             <a:off x="1051560" y="1979676"/>
-            <a:ext cx="3308299" cy="292608"/>
+            <a:ext cx="3453140" cy="292608"/>
           </a:xfrm>
           <a:prstGeom prst="roundRect">
             <a:avLst>
@@ -20972,7 +20972,7 @@
         <p:spPr>
           <a:xfrm>
             <a:off x="1161288" y="1979676"/>
-            <a:ext cx="3125419" cy="292608"/>
+            <a:ext cx="3270260" cy="292608"/>
           </a:xfrm>
           <a:prstGeom prst="rect">
             <a:avLst/>
@@ -20993,7 +20993,7 @@
                   <a:schemeClr val="bg1"/>
                 </a:solidFill>
               </a:rPr>
-              <a:t>Minuta de Contrato – cls. 7.4.1 e 13, XV</a:t>
+              <a:t>Minuta de Contrato – cls. 7.4.1 e 13.1, XV</a:t>
             </a:r>
             <a:endParaRPr lang="en-US" sz="1100" dirty="0"/>
           </a:p>

</xml_diff>

<commit_message>
CONSAÚDE: paleta própria (grafite e vinho) na planilha de vícios e no deck
Co-Authored-By: Claude Opus 5.5 <noreply@anthropic.com>
Claude-Session: https://claude.ai/code/session_01TrfDHY9D3MKaQfyrVNihp9
</commit_message>
<xml_diff>
--- a/concessoes/consaude-conc-2026/output/pontos-de-atencao-2026-10-08.pptx
+++ b/concessoes/consaude-conc-2026/output/pontos-de-atencao-2026-10-08.pptx
@@ -129,18 +129,18 @@
   <p:extLst>
     <p:ext uri="{521415D9-36F7-43E2-AB2F-B90AF26B5E84}">
       <p14:sectionLst xmlns:p14="http://schemas.microsoft.com/office/powerpoint/2010/main">
-        <p14:section name="Capa" id="{6c319b7f-c809-7768-218b-ccf9feb7074d}">
+        <p14:section name="Capa" id="{ee872925-b961-00ba-d7ea-d4d8b450eeac}">
           <p14:sldIdLst>
             <p14:sldId id="256"/>
           </p14:sldIdLst>
         </p14:section>
-        <p14:section name="Informações Gerais" id="{77bc1f84-fcf0-fefc-e964-7d155c602d34}">
+        <p14:section name="Informações Gerais" id="{a1011189-e439-5077-05c8-c30852fedc4e}">
           <p14:sldIdLst>
             <p14:sldId id="257"/>
             <p14:sldId id="258"/>
           </p14:sldIdLst>
         </p14:section>
-        <p14:section name="Aspectos Jurídicos Estratégicos" id="{01305890-6539-50fa-d98e-7ce2201c59ef}">
+        <p14:section name="Aspectos Jurídicos Estratégicos" id="{270898ef-8e54-4b31-0d56-e87376948a51}">
           <p14:sldIdLst>
             <p14:sldId id="259"/>
             <p14:sldId id="260"/>
@@ -160,14 +160,14 @@
             <p14:sldId id="274"/>
           </p14:sldIdLst>
         </p14:section>
-        <p14:section name="Pontos de atenção" id="{48464bc7-604a-6e65-16d6-5c46f594292c}">
+        <p14:section name="Pontos de atenção" id="{f322d27d-c6ea-318c-045f-7e56db94fde8}">
           <p14:sldIdLst>
             <p14:sldId id="275"/>
             <p14:sldId id="276"/>
             <p14:sldId id="277"/>
           </p14:sldIdLst>
         </p14:section>
-        <p14:section name="Encerramento" id="{3ffab46e-434d-d53b-d010-f2c8b6bd68b9}">
+        <p14:section name="Encerramento" id="{bef1c051-9926-ff76-a36d-b3a04cef1947}">
           <p14:sldIdLst>
             <p14:sldId id="278"/>
           </p14:sldIdLst>
@@ -236,11 +236,11 @@
           </c:tx>
           <c:spPr>
             <a:solidFill>
-              <a:srgbClr val="0B84C6"/>
+              <a:srgbClr val="8C2F39"/>
             </a:solidFill>
             <a:ln w="25400" cap="flat">
               <a:solidFill>
-                <a:srgbClr val="0B84C6"/>
+                <a:srgbClr val="8C2F39"/>
               </a:solidFill>
               <a:prstDash val="solid"/>
               <a:round/>
@@ -277,11 +277,11 @@
             <c:size val="6"/>
             <c:spPr>
               <a:solidFill>
-                <a:srgbClr val="0B84C6"/>
+                <a:srgbClr val="8C2F39"/>
               </a:solidFill>
               <a:ln w="9525" cap="flat">
                 <a:solidFill>
-                  <a:srgbClr val="0B84C6"/>
+                  <a:srgbClr val="8C2F39"/>
                 </a:solidFill>
                 <a:prstDash val="solid"/>
                 <a:round/>
@@ -715,7 +715,7 @@
                 <a:pPr>
                   <a:defRPr sz="900" b="0" i="0" u="none" strike="noStrike">
                     <a:solidFill>
-                      <a:srgbClr val="6B7480"/>
+                      <a:srgbClr val="6B7076"/>
                     </a:solidFill>
                     <a:latin typeface="Arial"/>
                   </a:defRPr>
@@ -723,7 +723,7 @@
                 <a:r>
                   <a:rPr sz="900" b="0" i="0" u="none" strike="noStrike">
                     <a:solidFill>
-                      <a:srgbClr val="6B7480"/>
+                      <a:srgbClr val="6B7076"/>
                     </a:solidFill>
                     <a:latin typeface="Arial"/>
                   </a:rPr>
@@ -755,7 +755,7 @@
             <a:pPr>
               <a:defRPr sz="900" b="0" i="0" u="none" strike="noStrike">
                 <a:solidFill>
-                  <a:srgbClr val="6B7480"/>
+                  <a:srgbClr val="6B7076"/>
                 </a:solidFill>
                 <a:latin typeface="+mn-lt"/>
               </a:defRPr>
@@ -809,7 +809,7 @@
             <a:pPr>
               <a:defRPr sz="900" b="0" i="0" u="none" strike="noStrike">
                 <a:solidFill>
-                  <a:srgbClr val="6B7480"/>
+                  <a:srgbClr val="6B7076"/>
                 </a:solidFill>
                 <a:latin typeface="+mn-lt"/>
               </a:defRPr>
@@ -923,7 +923,7 @@
           </c:tx>
           <c:spPr>
             <a:solidFill>
-              <a:srgbClr val="6B7480"/>
+              <a:srgbClr val="6B7076"/>
             </a:solidFill>
             <a:effectLst/>
           </c:spPr>
@@ -1007,7 +1007,7 @@
           </c:tx>
           <c:spPr>
             <a:solidFill>
-              <a:srgbClr val="075E8D"/>
+              <a:srgbClr val="5E1D25"/>
             </a:solidFill>
             <a:effectLst/>
           </c:spPr>
@@ -1091,7 +1091,7 @@
           </c:tx>
           <c:spPr>
             <a:solidFill>
-              <a:srgbClr val="0B84C6"/>
+              <a:srgbClr val="8C2F39"/>
             </a:solidFill>
             <a:effectLst/>
           </c:spPr>
@@ -4369,7 +4369,7 @@
           </a:prstGeom>
           <a:ln w="15875">
             <a:solidFill>
-              <a:schemeClr val="accent1"/>
+              <a:schemeClr val="accent3"/>
             </a:solidFill>
             <a:prstDash val="solid"/>
           </a:ln>
@@ -4391,7 +4391,7 @@
           </a:prstGeom>
           <a:ln w="12700">
             <a:solidFill>
-              <a:schemeClr val="accent1"/>
+              <a:schemeClr val="accent3"/>
             </a:solidFill>
             <a:prstDash val="solid"/>
           </a:ln>
@@ -4413,7 +4413,7 @@
           </a:prstGeom>
           <a:ln w="9525">
             <a:solidFill>
-              <a:schemeClr val="accent1"/>
+              <a:schemeClr val="accent3"/>
             </a:solidFill>
             <a:prstDash val="solid"/>
           </a:ln>
@@ -4435,7 +4435,7 @@
           </a:prstGeom>
           <a:ln w="9525">
             <a:solidFill>
-              <a:schemeClr val="accent1"/>
+              <a:schemeClr val="accent3"/>
             </a:solidFill>
             <a:prstDash val="solid"/>
           </a:ln>
@@ -14003,7 +14003,7 @@
                       <a:tailEnd type="none" w="med" len="med"/>
                     </a:lnB>
                     <a:solidFill>
-                      <a:srgbClr val="0B84C6"/>
+                      <a:srgbClr val="8C2F39"/>
                     </a:solidFill>
                   </a:tcPr>
                 </a:tc>
@@ -14071,7 +14071,7 @@
                       <a:tailEnd type="none" w="med" len="med"/>
                     </a:lnB>
                     <a:solidFill>
-                      <a:srgbClr val="0B84C6"/>
+                      <a:srgbClr val="8C2F39"/>
                     </a:solidFill>
                   </a:tcPr>
                 </a:tc>
@@ -14139,7 +14139,7 @@
                       <a:tailEnd type="none" w="med" len="med"/>
                     </a:lnB>
                     <a:solidFill>
-                      <a:srgbClr val="0B84C6"/>
+                      <a:srgbClr val="8C2F39"/>
                     </a:solidFill>
                   </a:tcPr>
                 </a:tc>
@@ -14209,7 +14209,7 @@
                       <a:tailEnd type="none" w="med" len="med"/>
                     </a:lnB>
                     <a:solidFill>
-                      <a:srgbClr val="EEF1F4"/>
+                      <a:srgbClr val="F1F2F3"/>
                     </a:solidFill>
                   </a:tcPr>
                 </a:tc>
@@ -14277,7 +14277,7 @@
                       <a:tailEnd type="none" w="med" len="med"/>
                     </a:lnB>
                     <a:solidFill>
-                      <a:srgbClr val="EEF1F4"/>
+                      <a:srgbClr val="F1F2F3"/>
                     </a:solidFill>
                   </a:tcPr>
                 </a:tc>
@@ -14345,7 +14345,7 @@
                       <a:tailEnd type="none" w="med" len="med"/>
                     </a:lnB>
                     <a:solidFill>
-                      <a:srgbClr val="EEF1F4"/>
+                      <a:srgbClr val="F1F2F3"/>
                     </a:solidFill>
                   </a:tcPr>
                 </a:tc>
@@ -14415,7 +14415,7 @@
                       <a:tailEnd type="none" w="med" len="med"/>
                     </a:lnB>
                     <a:solidFill>
-                      <a:srgbClr val="EEF1F4"/>
+                      <a:srgbClr val="F1F2F3"/>
                     </a:solidFill>
                   </a:tcPr>
                 </a:tc>
@@ -14483,7 +14483,7 @@
                       <a:tailEnd type="none" w="med" len="med"/>
                     </a:lnB>
                     <a:solidFill>
-                      <a:srgbClr val="EEF1F4"/>
+                      <a:srgbClr val="F1F2F3"/>
                     </a:solidFill>
                   </a:tcPr>
                 </a:tc>
@@ -14551,7 +14551,7 @@
                       <a:tailEnd type="none" w="med" len="med"/>
                     </a:lnB>
                     <a:solidFill>
-                      <a:srgbClr val="EEF1F4"/>
+                      <a:srgbClr val="F1F2F3"/>
                     </a:solidFill>
                   </a:tcPr>
                 </a:tc>
@@ -14621,7 +14621,7 @@
                       <a:tailEnd type="none" w="med" len="med"/>
                     </a:lnB>
                     <a:solidFill>
-                      <a:srgbClr val="EEF1F4"/>
+                      <a:srgbClr val="F1F2F3"/>
                     </a:solidFill>
                   </a:tcPr>
                 </a:tc>
@@ -14689,7 +14689,7 @@
                       <a:tailEnd type="none" w="med" len="med"/>
                     </a:lnB>
                     <a:solidFill>
-                      <a:srgbClr val="EEF1F4"/>
+                      <a:srgbClr val="F1F2F3"/>
                     </a:solidFill>
                   </a:tcPr>
                 </a:tc>
@@ -14757,7 +14757,7 @@
                       <a:tailEnd type="none" w="med" len="med"/>
                     </a:lnB>
                     <a:solidFill>
-                      <a:srgbClr val="EEF1F4"/>
+                      <a:srgbClr val="F1F2F3"/>
                     </a:solidFill>
                   </a:tcPr>
                 </a:tc>
@@ -14827,7 +14827,7 @@
                       <a:tailEnd type="none" w="med" len="med"/>
                     </a:lnB>
                     <a:solidFill>
-                      <a:srgbClr val="EEF1F4"/>
+                      <a:srgbClr val="F1F2F3"/>
                     </a:solidFill>
                   </a:tcPr>
                 </a:tc>
@@ -14895,7 +14895,7 @@
                       <a:tailEnd type="none" w="med" len="med"/>
                     </a:lnB>
                     <a:solidFill>
-                      <a:srgbClr val="EEF1F4"/>
+                      <a:srgbClr val="F1F2F3"/>
                     </a:solidFill>
                   </a:tcPr>
                 </a:tc>
@@ -14963,7 +14963,7 @@
                       <a:tailEnd type="none" w="med" len="med"/>
                     </a:lnB>
                     <a:solidFill>
-                      <a:srgbClr val="EEF1F4"/>
+                      <a:srgbClr val="F1F2F3"/>
                     </a:solidFill>
                   </a:tcPr>
                 </a:tc>
@@ -15033,7 +15033,7 @@
                       <a:tailEnd type="none" w="med" len="med"/>
                     </a:lnB>
                     <a:solidFill>
-                      <a:srgbClr val="EEF1F4"/>
+                      <a:srgbClr val="F1F2F3"/>
                     </a:solidFill>
                   </a:tcPr>
                 </a:tc>
@@ -15101,7 +15101,7 @@
                       <a:tailEnd type="none" w="med" len="med"/>
                     </a:lnB>
                     <a:solidFill>
-                      <a:srgbClr val="EEF1F4"/>
+                      <a:srgbClr val="F1F2F3"/>
                     </a:solidFill>
                   </a:tcPr>
                 </a:tc>
@@ -15169,7 +15169,7 @@
                       <a:tailEnd type="none" w="med" len="med"/>
                     </a:lnB>
                     <a:solidFill>
-                      <a:srgbClr val="EEF1F4"/>
+                      <a:srgbClr val="F1F2F3"/>
                     </a:solidFill>
                   </a:tcPr>
                 </a:tc>
@@ -15264,7 +15264,7 @@
           </a:prstGeom>
           <a:ln w="15875">
             <a:solidFill>
-              <a:schemeClr val="accent1"/>
+              <a:schemeClr val="accent3"/>
             </a:solidFill>
             <a:prstDash val="solid"/>
           </a:ln>
@@ -15286,7 +15286,7 @@
           </a:prstGeom>
           <a:ln w="12700">
             <a:solidFill>
-              <a:schemeClr val="accent1"/>
+              <a:schemeClr val="accent3"/>
             </a:solidFill>
             <a:prstDash val="solid"/>
           </a:ln>
@@ -15308,7 +15308,7 @@
           </a:prstGeom>
           <a:ln w="9525">
             <a:solidFill>
-              <a:schemeClr val="accent1"/>
+              <a:schemeClr val="accent3"/>
             </a:solidFill>
             <a:prstDash val="solid"/>
           </a:ln>
@@ -15777,7 +15777,7 @@
                       <a:tailEnd type="none" w="med" len="med"/>
                     </a:lnB>
                     <a:solidFill>
-                      <a:srgbClr val="0B84C6"/>
+                      <a:srgbClr val="8C2F39"/>
                     </a:solidFill>
                   </a:tcPr>
                 </a:tc>
@@ -15850,7 +15850,7 @@
                       <a:tailEnd type="none" w="med" len="med"/>
                     </a:lnB>
                     <a:solidFill>
-                      <a:srgbClr val="6B7480"/>
+                      <a:srgbClr val="6B7076"/>
                     </a:solidFill>
                   </a:tcPr>
                 </a:tc>
@@ -15918,7 +15918,7 @@
                       <a:tailEnd type="none" w="med" len="med"/>
                     </a:lnB>
                     <a:solidFill>
-                      <a:srgbClr val="EEF1F4"/>
+                      <a:srgbClr val="F1F2F3"/>
                     </a:solidFill>
                   </a:tcPr>
                 </a:tc>
@@ -15988,7 +15988,7 @@
                       <a:tailEnd type="none" w="med" len="med"/>
                     </a:lnB>
                     <a:solidFill>
-                      <a:srgbClr val="6B7480"/>
+                      <a:srgbClr val="6B7076"/>
                     </a:solidFill>
                   </a:tcPr>
                 </a:tc>
@@ -16056,7 +16056,7 @@
                       <a:tailEnd type="none" w="med" len="med"/>
                     </a:lnB>
                     <a:solidFill>
-                      <a:srgbClr val="EEF1F4"/>
+                      <a:srgbClr val="F1F2F3"/>
                     </a:solidFill>
                   </a:tcPr>
                 </a:tc>
@@ -16126,7 +16126,7 @@
                       <a:tailEnd type="none" w="med" len="med"/>
                     </a:lnB>
                     <a:solidFill>
-                      <a:srgbClr val="6B7480"/>
+                      <a:srgbClr val="6B7076"/>
                     </a:solidFill>
                   </a:tcPr>
                 </a:tc>
@@ -16194,7 +16194,7 @@
                       <a:tailEnd type="none" w="med" len="med"/>
                     </a:lnB>
                     <a:solidFill>
-                      <a:srgbClr val="EEF1F4"/>
+                      <a:srgbClr val="F1F2F3"/>
                     </a:solidFill>
                   </a:tcPr>
                 </a:tc>
@@ -16264,7 +16264,7 @@
                       <a:tailEnd type="none" w="med" len="med"/>
                     </a:lnB>
                     <a:solidFill>
-                      <a:srgbClr val="6B7480"/>
+                      <a:srgbClr val="6B7076"/>
                     </a:solidFill>
                   </a:tcPr>
                 </a:tc>
@@ -16332,7 +16332,7 @@
                       <a:tailEnd type="none" w="med" len="med"/>
                     </a:lnB>
                     <a:solidFill>
-                      <a:srgbClr val="EEF1F4"/>
+                      <a:srgbClr val="F1F2F3"/>
                     </a:solidFill>
                   </a:tcPr>
                 </a:tc>
@@ -16402,7 +16402,7 @@
                       <a:tailEnd type="none" w="med" len="med"/>
                     </a:lnB>
                     <a:solidFill>
-                      <a:srgbClr val="6B7480"/>
+                      <a:srgbClr val="6B7076"/>
                     </a:solidFill>
                   </a:tcPr>
                 </a:tc>
@@ -16470,7 +16470,7 @@
                       <a:tailEnd type="none" w="med" len="med"/>
                     </a:lnB>
                     <a:solidFill>
-                      <a:srgbClr val="EEF1F4"/>
+                      <a:srgbClr val="F1F2F3"/>
                     </a:solidFill>
                   </a:tcPr>
                 </a:tc>
@@ -16540,7 +16540,7 @@
                       <a:tailEnd type="none" w="med" len="med"/>
                     </a:lnB>
                     <a:solidFill>
-                      <a:srgbClr val="6B7480"/>
+                      <a:srgbClr val="6B7076"/>
                     </a:solidFill>
                   </a:tcPr>
                 </a:tc>
@@ -16608,7 +16608,7 @@
                       <a:tailEnd type="none" w="med" len="med"/>
                     </a:lnB>
                     <a:solidFill>
-                      <a:srgbClr val="EEF1F4"/>
+                      <a:srgbClr val="F1F2F3"/>
                     </a:solidFill>
                   </a:tcPr>
                 </a:tc>
@@ -16678,7 +16678,7 @@
                       <a:tailEnd type="none" w="med" len="med"/>
                     </a:lnB>
                     <a:solidFill>
-                      <a:srgbClr val="6B7480"/>
+                      <a:srgbClr val="6B7076"/>
                     </a:solidFill>
                   </a:tcPr>
                 </a:tc>
@@ -16746,7 +16746,7 @@
                       <a:tailEnd type="none" w="med" len="med"/>
                     </a:lnB>
                     <a:solidFill>
-                      <a:srgbClr val="EEF1F4"/>
+                      <a:srgbClr val="F1F2F3"/>
                     </a:solidFill>
                   </a:tcPr>
                 </a:tc>
@@ -16816,7 +16816,7 @@
                       <a:tailEnd type="none" w="med" len="med"/>
                     </a:lnB>
                     <a:solidFill>
-                      <a:srgbClr val="6B7480"/>
+                      <a:srgbClr val="6B7076"/>
                     </a:solidFill>
                   </a:tcPr>
                 </a:tc>
@@ -16884,7 +16884,7 @@
                       <a:tailEnd type="none" w="med" len="med"/>
                     </a:lnB>
                     <a:solidFill>
-                      <a:srgbClr val="EEF1F4"/>
+                      <a:srgbClr val="F1F2F3"/>
                     </a:solidFill>
                   </a:tcPr>
                 </a:tc>
@@ -16954,7 +16954,7 @@
                       <a:tailEnd type="none" w="med" len="med"/>
                     </a:lnB>
                     <a:solidFill>
-                      <a:srgbClr val="6B7480"/>
+                      <a:srgbClr val="6B7076"/>
                     </a:solidFill>
                   </a:tcPr>
                 </a:tc>
@@ -17022,7 +17022,7 @@
                       <a:tailEnd type="none" w="med" len="med"/>
                     </a:lnB>
                     <a:solidFill>
-                      <a:srgbClr val="EEF1F4"/>
+                      <a:srgbClr val="F1F2F3"/>
                     </a:solidFill>
                   </a:tcPr>
                 </a:tc>
@@ -17092,7 +17092,7 @@
                       <a:tailEnd type="none" w="med" len="med"/>
                     </a:lnB>
                     <a:solidFill>
-                      <a:srgbClr val="6B7480"/>
+                      <a:srgbClr val="6B7076"/>
                     </a:solidFill>
                   </a:tcPr>
                 </a:tc>
@@ -17160,7 +17160,7 @@
                       <a:tailEnd type="none" w="med" len="med"/>
                     </a:lnB>
                     <a:solidFill>
-                      <a:srgbClr val="EEF1F4"/>
+                      <a:srgbClr val="F1F2F3"/>
                     </a:solidFill>
                   </a:tcPr>
                 </a:tc>
@@ -17230,7 +17230,7 @@
                       <a:tailEnd type="none" w="med" len="med"/>
                     </a:lnB>
                     <a:solidFill>
-                      <a:srgbClr val="6B7480"/>
+                      <a:srgbClr val="6B7076"/>
                     </a:solidFill>
                   </a:tcPr>
                 </a:tc>
@@ -17298,7 +17298,7 @@
                       <a:tailEnd type="none" w="med" len="med"/>
                     </a:lnB>
                     <a:solidFill>
-                      <a:srgbClr val="EEF1F4"/>
+                      <a:srgbClr val="F1F2F3"/>
                     </a:solidFill>
                   </a:tcPr>
                 </a:tc>
@@ -17368,7 +17368,7 @@
                       <a:tailEnd type="none" w="med" len="med"/>
                     </a:lnB>
                     <a:solidFill>
-                      <a:srgbClr val="6B7480"/>
+                      <a:srgbClr val="6B7076"/>
                     </a:solidFill>
                   </a:tcPr>
                 </a:tc>
@@ -17436,7 +17436,7 @@
                       <a:tailEnd type="none" w="med" len="med"/>
                     </a:lnB>
                     <a:solidFill>
-                      <a:srgbClr val="EEF1F4"/>
+                      <a:srgbClr val="F1F2F3"/>
                     </a:solidFill>
                   </a:tcPr>
                 </a:tc>
@@ -17506,7 +17506,7 @@
                       <a:tailEnd type="none" w="med" len="med"/>
                     </a:lnB>
                     <a:solidFill>
-                      <a:srgbClr val="6B7480"/>
+                      <a:srgbClr val="6B7076"/>
                     </a:solidFill>
                   </a:tcPr>
                 </a:tc>
@@ -17574,7 +17574,7 @@
                       <a:tailEnd type="none" w="med" len="med"/>
                     </a:lnB>
                     <a:solidFill>
-                      <a:srgbClr val="EEF1F4"/>
+                      <a:srgbClr val="F1F2F3"/>
                     </a:solidFill>
                   </a:tcPr>
                 </a:tc>
@@ -17644,7 +17644,7 @@
                       <a:tailEnd type="none" w="med" len="med"/>
                     </a:lnB>
                     <a:solidFill>
-                      <a:srgbClr val="6B7480"/>
+                      <a:srgbClr val="6B7076"/>
                     </a:solidFill>
                   </a:tcPr>
                 </a:tc>
@@ -17712,7 +17712,7 @@
                       <a:tailEnd type="none" w="med" len="med"/>
                     </a:lnB>
                     <a:solidFill>
-                      <a:srgbClr val="EEF1F4"/>
+                      <a:srgbClr val="F1F2F3"/>
                     </a:solidFill>
                   </a:tcPr>
                 </a:tc>
@@ -21468,34 +21468,34 @@
         <a:srgbClr val="FFFFFF"/>
       </a:lt1>
       <a:dk2>
-        <a:srgbClr val="383D42"/>
+        <a:srgbClr val="2E3236"/>
       </a:dk2>
       <a:lt2>
-        <a:srgbClr val="EEF1F4"/>
+        <a:srgbClr val="F1F2F3"/>
       </a:lt2>
       <a:accent1>
-        <a:srgbClr val="0B84C6"/>
+        <a:srgbClr val="8C2F39"/>
       </a:accent1>
       <a:accent2>
-        <a:srgbClr val="075E8D"/>
+        <a:srgbClr val="5E1D25"/>
       </a:accent2>
       <a:accent3>
-        <a:srgbClr val="CFE6F4"/>
+        <a:srgbClr val="D9B8BC"/>
       </a:accent3>
       <a:accent4>
-        <a:srgbClr val="6B7480"/>
+        <a:srgbClr val="6B7076"/>
       </a:accent4>
       <a:accent5>
-        <a:srgbClr val="D5DBE1"/>
+        <a:srgbClr val="D6D9DC"/>
       </a:accent5>
       <a:accent6>
-        <a:srgbClr val="B23A48"/>
+        <a:srgbClr val="A8646C"/>
       </a:accent6>
       <a:hlink>
-        <a:srgbClr val="0B84C6"/>
+        <a:srgbClr val="8C2F39"/>
       </a:hlink>
       <a:folHlink>
-        <a:srgbClr val="075E8D"/>
+        <a:srgbClr val="5E1D25"/>
       </a:folHlink>
     </a:clrScheme>
     <a:fontScheme name="Pontos de atencao">

</xml_diff>

<commit_message>
CONSAÚDE: identidade verde e branca na planilha de vícios e no deck
Co-Authored-By: Claude Opus 5.5 <noreply@anthropic.com>
Claude-Session: https://claude.ai/code/session_01TrfDHY9D3MKaQfyrVNihp9
</commit_message>
<xml_diff>
--- a/concessoes/consaude-conc-2026/output/pontos-de-atencao-2026-10-08.pptx
+++ b/concessoes/consaude-conc-2026/output/pontos-de-atencao-2026-10-08.pptx
@@ -129,18 +129,18 @@
   <p:extLst>
     <p:ext uri="{521415D9-36F7-43E2-AB2F-B90AF26B5E84}">
       <p14:sectionLst xmlns:p14="http://schemas.microsoft.com/office/powerpoint/2010/main">
-        <p14:section name="Capa" id="{ee872925-b961-00ba-d7ea-d4d8b450eeac}">
+        <p14:section name="Capa" id="{34c5be09-b295-f26a-9385-30b23add58c2}">
           <p14:sldIdLst>
             <p14:sldId id="256"/>
           </p14:sldIdLst>
         </p14:section>
-        <p14:section name="Informações Gerais" id="{a1011189-e439-5077-05c8-c30852fedc4e}">
+        <p14:section name="Informações Gerais" id="{16fc235d-a10a-8ebc-1c17-8fa5d42d51bf}">
           <p14:sldIdLst>
             <p14:sldId id="257"/>
             <p14:sldId id="258"/>
           </p14:sldIdLst>
         </p14:section>
-        <p14:section name="Aspectos Jurídicos Estratégicos" id="{270898ef-8e54-4b31-0d56-e87376948a51}">
+        <p14:section name="Aspectos Jurídicos Estratégicos" id="{89338755-8c45-a1fa-4b16-84a14470d5b7}">
           <p14:sldIdLst>
             <p14:sldId id="259"/>
             <p14:sldId id="260"/>
@@ -160,14 +160,14 @@
             <p14:sldId id="274"/>
           </p14:sldIdLst>
         </p14:section>
-        <p14:section name="Pontos de atenção" id="{f322d27d-c6ea-318c-045f-7e56db94fde8}">
+        <p14:section name="Pontos de atenção" id="{65c70825-d3f3-a581-f8dc-861340db2c0a}">
           <p14:sldIdLst>
             <p14:sldId id="275"/>
             <p14:sldId id="276"/>
             <p14:sldId id="277"/>
           </p14:sldIdLst>
         </p14:section>
-        <p14:section name="Encerramento" id="{bef1c051-9926-ff76-a36d-b3a04cef1947}">
+        <p14:section name="Encerramento" id="{21068c8b-ee69-5439-4147-d01420f951b0}">
           <p14:sldIdLst>
             <p14:sldId id="278"/>
           </p14:sldIdLst>
@@ -195,7 +195,7 @@
             <a:pPr>
               <a:defRPr sz="1100" b="0" i="0" u="none" strike="noStrike">
                 <a:solidFill>
-                  <a:srgbClr val="1F2328"/>
+                  <a:srgbClr val="373435"/>
                 </a:solidFill>
                 <a:latin typeface="+mn-lt"/>
               </a:defRPr>
@@ -203,7 +203,7 @@
             <a:r>
               <a:rPr sz="1100" b="0" i="0" u="none" strike="noStrike">
                 <a:solidFill>
-                  <a:srgbClr val="1F2328"/>
+                  <a:srgbClr val="373435"/>
                 </a:solidFill>
                 <a:latin typeface="+mn-lt"/>
               </a:rPr>
@@ -236,11 +236,11 @@
           </c:tx>
           <c:spPr>
             <a:solidFill>
-              <a:srgbClr val="8C2F39"/>
+              <a:srgbClr val="00703C"/>
             </a:solidFill>
             <a:ln w="25400" cap="flat">
               <a:solidFill>
-                <a:srgbClr val="8C2F39"/>
+                <a:srgbClr val="00703C"/>
               </a:solidFill>
               <a:prstDash val="solid"/>
               <a:round/>
@@ -277,11 +277,11 @@
             <c:size val="6"/>
             <c:spPr>
               <a:solidFill>
-                <a:srgbClr val="8C2F39"/>
+                <a:srgbClr val="00703C"/>
               </a:solidFill>
               <a:ln w="9525" cap="flat">
                 <a:solidFill>
-                  <a:srgbClr val="8C2F39"/>
+                  <a:srgbClr val="00703C"/>
                 </a:solidFill>
                 <a:prstDash val="solid"/>
                 <a:round/>
@@ -715,7 +715,7 @@
                 <a:pPr>
                   <a:defRPr sz="900" b="0" i="0" u="none" strike="noStrike">
                     <a:solidFill>
-                      <a:srgbClr val="6B7076"/>
+                      <a:srgbClr val="6E6B6C"/>
                     </a:solidFill>
                     <a:latin typeface="Arial"/>
                   </a:defRPr>
@@ -723,7 +723,7 @@
                 <a:r>
                   <a:rPr sz="900" b="0" i="0" u="none" strike="noStrike">
                     <a:solidFill>
-                      <a:srgbClr val="6B7076"/>
+                      <a:srgbClr val="6E6B6C"/>
                     </a:solidFill>
                     <a:latin typeface="Arial"/>
                   </a:rPr>
@@ -755,7 +755,7 @@
             <a:pPr>
               <a:defRPr sz="900" b="0" i="0" u="none" strike="noStrike">
                 <a:solidFill>
-                  <a:srgbClr val="6B7076"/>
+                  <a:srgbClr val="6E6B6C"/>
                 </a:solidFill>
                 <a:latin typeface="+mn-lt"/>
               </a:defRPr>
@@ -809,7 +809,7 @@
             <a:pPr>
               <a:defRPr sz="900" b="0" i="0" u="none" strike="noStrike">
                 <a:solidFill>
-                  <a:srgbClr val="6B7076"/>
+                  <a:srgbClr val="6E6B6C"/>
                 </a:solidFill>
                 <a:latin typeface="+mn-lt"/>
               </a:defRPr>
@@ -840,7 +840,7 @@
           <a:pPr>
             <a:defRPr sz="900">
               <a:solidFill>
-                <a:srgbClr val="1F2328"/>
+                <a:srgbClr val="373435"/>
               </a:solidFill>
               <a:latin typeface="+mn-lt"/>
               <a:cs typeface="+mn-lt"/>
@@ -880,7 +880,7 @@
             <a:pPr>
               <a:defRPr sz="1100" b="0" i="0" u="none" strike="noStrike">
                 <a:solidFill>
-                  <a:srgbClr val="1F2328"/>
+                  <a:srgbClr val="373435"/>
                 </a:solidFill>
                 <a:latin typeface="+mn-lt"/>
               </a:defRPr>
@@ -888,7 +888,7 @@
             <a:r>
               <a:rPr sz="1100" b="0" i="0" u="none" strike="noStrike">
                 <a:solidFill>
-                  <a:srgbClr val="1F2328"/>
+                  <a:srgbClr val="373435"/>
                 </a:solidFill>
                 <a:latin typeface="+mn-lt"/>
               </a:rPr>
@@ -923,7 +923,7 @@
           </c:tx>
           <c:spPr>
             <a:solidFill>
-              <a:srgbClr val="6B7076"/>
+              <a:srgbClr val="6E6B6C"/>
             </a:solidFill>
             <a:effectLst/>
           </c:spPr>
@@ -1007,7 +1007,7 @@
           </c:tx>
           <c:spPr>
             <a:solidFill>
-              <a:srgbClr val="5E1D25"/>
+              <a:srgbClr val="373435"/>
             </a:solidFill>
             <a:effectLst/>
           </c:spPr>
@@ -1091,7 +1091,7 @@
           </c:tx>
           <c:spPr>
             <a:solidFill>
-              <a:srgbClr val="8C2F39"/>
+              <a:srgbClr val="00703C"/>
             </a:solidFill>
             <a:effectLst/>
           </c:spPr>
@@ -1217,7 +1217,7 @@
             <a:pPr>
               <a:defRPr sz="1000" b="0" i="0" u="none" strike="noStrike">
                 <a:solidFill>
-                  <a:srgbClr val="1F2328"/>
+                  <a:srgbClr val="373435"/>
                 </a:solidFill>
                 <a:latin typeface="+mn-lt"/>
               </a:defRPr>
@@ -1288,7 +1288,7 @@
           <a:pPr>
             <a:defRPr sz="900">
               <a:solidFill>
-                <a:srgbClr val="1F2328"/>
+                <a:srgbClr val="373435"/>
               </a:solidFill>
               <a:latin typeface="+mn-lt"/>
               <a:cs typeface="+mn-lt"/>
@@ -3799,7 +3799,7 @@
               <a:buNone/>
               <a:defRPr lang="en-US" sz="4800" b="1" dirty="0">
                 <a:solidFill>
-                  <a:schemeClr val="bg1"/>
+                  <a:schemeClr val="tx2"/>
                 </a:solidFill>
               </a:defRPr>
             </a:lvl1pPr>
@@ -12141,7 +12141,7 @@
           </a:prstGeom>
           <a:ln w="9525">
             <a:solidFill>
-              <a:schemeClr val="accent4"/>
+              <a:schemeClr val="accent3"/>
             </a:solidFill>
             <a:prstDash val="solid"/>
           </a:ln>
@@ -12163,7 +12163,7 @@
           </a:prstGeom>
           <a:ln w="9525">
             <a:solidFill>
-              <a:schemeClr val="accent4"/>
+              <a:schemeClr val="accent3"/>
             </a:solidFill>
             <a:prstDash val="solid"/>
           </a:ln>
@@ -12184,7 +12184,7 @@
             <a:avLst/>
           </a:prstGeom>
           <a:solidFill>
-            <a:schemeClr val="accent1"/>
+            <a:schemeClr val="bg1"/>
           </a:solidFill>
           <a:ln/>
         </p:spPr>
@@ -12218,7 +12218,7 @@
             <a:r>
               <a:rPr lang="en-US" sz="4800" b="1" dirty="0">
                 <a:solidFill>
-                  <a:schemeClr val="bg1"/>
+                  <a:schemeClr val="tx2"/>
                 </a:solidFill>
               </a:rPr>
               <a:t>1</a:t>
@@ -14003,7 +14003,7 @@
                       <a:tailEnd type="none" w="med" len="med"/>
                     </a:lnB>
                     <a:solidFill>
-                      <a:srgbClr val="8C2F39"/>
+                      <a:srgbClr val="00703C"/>
                     </a:solidFill>
                   </a:tcPr>
                 </a:tc>
@@ -14071,7 +14071,7 @@
                       <a:tailEnd type="none" w="med" len="med"/>
                     </a:lnB>
                     <a:solidFill>
-                      <a:srgbClr val="8C2F39"/>
+                      <a:srgbClr val="00703C"/>
                     </a:solidFill>
                   </a:tcPr>
                 </a:tc>
@@ -14139,7 +14139,7 @@
                       <a:tailEnd type="none" w="med" len="med"/>
                     </a:lnB>
                     <a:solidFill>
-                      <a:srgbClr val="8C2F39"/>
+                      <a:srgbClr val="00703C"/>
                     </a:solidFill>
                   </a:tcPr>
                 </a:tc>
@@ -14156,7 +14156,7 @@
                       <a:r>
                         <a:rPr lang="en-US" sz="1250" b="1" dirty="0">
                           <a:solidFill>
-                            <a:srgbClr val="1F2328"/>
+                            <a:srgbClr val="373435"/>
                           </a:solidFill>
                           <a:latin typeface="Calibri" pitchFamily="34" charset="0"/>
                           <a:ea typeface="Calibri" pitchFamily="34" charset="-122"/>
@@ -14209,7 +14209,7 @@
                       <a:tailEnd type="none" w="med" len="med"/>
                     </a:lnB>
                     <a:solidFill>
-                      <a:srgbClr val="F1F2F3"/>
+                      <a:srgbClr val="EEF4F0"/>
                     </a:solidFill>
                   </a:tcPr>
                 </a:tc>
@@ -14224,7 +14224,7 @@
                       <a:r>
                         <a:rPr lang="en-US" sz="1250" dirty="0">
                           <a:solidFill>
-                            <a:srgbClr val="1F2328"/>
+                            <a:srgbClr val="373435"/>
                           </a:solidFill>
                           <a:latin typeface="Calibri" pitchFamily="34" charset="0"/>
                           <a:ea typeface="Calibri" pitchFamily="34" charset="-122"/>
@@ -14277,7 +14277,7 @@
                       <a:tailEnd type="none" w="med" len="med"/>
                     </a:lnB>
                     <a:solidFill>
-                      <a:srgbClr val="F1F2F3"/>
+                      <a:srgbClr val="EEF4F0"/>
                     </a:solidFill>
                   </a:tcPr>
                 </a:tc>
@@ -14292,7 +14292,7 @@
                       <a:r>
                         <a:rPr lang="en-US" sz="1250" dirty="0">
                           <a:solidFill>
-                            <a:srgbClr val="1F2328"/>
+                            <a:srgbClr val="373435"/>
                           </a:solidFill>
                           <a:latin typeface="Calibri" pitchFamily="34" charset="0"/>
                           <a:ea typeface="Calibri" pitchFamily="34" charset="-122"/>
@@ -14345,7 +14345,7 @@
                       <a:tailEnd type="none" w="med" len="med"/>
                     </a:lnB>
                     <a:solidFill>
-                      <a:srgbClr val="F1F2F3"/>
+                      <a:srgbClr val="EEF4F0"/>
                     </a:solidFill>
                   </a:tcPr>
                 </a:tc>
@@ -14362,7 +14362,7 @@
                       <a:r>
                         <a:rPr lang="en-US" sz="1250" b="1" dirty="0">
                           <a:solidFill>
-                            <a:srgbClr val="1F2328"/>
+                            <a:srgbClr val="373435"/>
                           </a:solidFill>
                           <a:latin typeface="Calibri" pitchFamily="34" charset="0"/>
                           <a:ea typeface="Calibri" pitchFamily="34" charset="-122"/>
@@ -14415,7 +14415,7 @@
                       <a:tailEnd type="none" w="med" len="med"/>
                     </a:lnB>
                     <a:solidFill>
-                      <a:srgbClr val="F1F2F3"/>
+                      <a:srgbClr val="EEF4F0"/>
                     </a:solidFill>
                   </a:tcPr>
                 </a:tc>
@@ -14430,7 +14430,7 @@
                       <a:r>
                         <a:rPr lang="en-US" sz="1250" dirty="0">
                           <a:solidFill>
-                            <a:srgbClr val="1F2328"/>
+                            <a:srgbClr val="373435"/>
                           </a:solidFill>
                           <a:latin typeface="Calibri" pitchFamily="34" charset="0"/>
                           <a:ea typeface="Calibri" pitchFamily="34" charset="-122"/>
@@ -14483,7 +14483,7 @@
                       <a:tailEnd type="none" w="med" len="med"/>
                     </a:lnB>
                     <a:solidFill>
-                      <a:srgbClr val="F1F2F3"/>
+                      <a:srgbClr val="EEF4F0"/>
                     </a:solidFill>
                   </a:tcPr>
                 </a:tc>
@@ -14498,7 +14498,7 @@
                       <a:r>
                         <a:rPr lang="en-US" sz="1250" dirty="0">
                           <a:solidFill>
-                            <a:srgbClr val="1F2328"/>
+                            <a:srgbClr val="373435"/>
                           </a:solidFill>
                           <a:latin typeface="Calibri" pitchFamily="34" charset="0"/>
                           <a:ea typeface="Calibri" pitchFamily="34" charset="-122"/>
@@ -14551,7 +14551,7 @@
                       <a:tailEnd type="none" w="med" len="med"/>
                     </a:lnB>
                     <a:solidFill>
-                      <a:srgbClr val="F1F2F3"/>
+                      <a:srgbClr val="EEF4F0"/>
                     </a:solidFill>
                   </a:tcPr>
                 </a:tc>
@@ -14568,7 +14568,7 @@
                       <a:r>
                         <a:rPr lang="en-US" sz="1250" b="1" dirty="0">
                           <a:solidFill>
-                            <a:srgbClr val="1F2328"/>
+                            <a:srgbClr val="373435"/>
                           </a:solidFill>
                           <a:latin typeface="Calibri" pitchFamily="34" charset="0"/>
                           <a:ea typeface="Calibri" pitchFamily="34" charset="-122"/>
@@ -14621,7 +14621,7 @@
                       <a:tailEnd type="none" w="med" len="med"/>
                     </a:lnB>
                     <a:solidFill>
-                      <a:srgbClr val="F1F2F3"/>
+                      <a:srgbClr val="EEF4F0"/>
                     </a:solidFill>
                   </a:tcPr>
                 </a:tc>
@@ -14636,7 +14636,7 @@
                       <a:r>
                         <a:rPr lang="en-US" sz="1250" dirty="0">
                           <a:solidFill>
-                            <a:srgbClr val="1F2328"/>
+                            <a:srgbClr val="373435"/>
                           </a:solidFill>
                           <a:latin typeface="Calibri" pitchFamily="34" charset="0"/>
                           <a:ea typeface="Calibri" pitchFamily="34" charset="-122"/>
@@ -14689,7 +14689,7 @@
                       <a:tailEnd type="none" w="med" len="med"/>
                     </a:lnB>
                     <a:solidFill>
-                      <a:srgbClr val="F1F2F3"/>
+                      <a:srgbClr val="EEF4F0"/>
                     </a:solidFill>
                   </a:tcPr>
                 </a:tc>
@@ -14704,7 +14704,7 @@
                       <a:r>
                         <a:rPr lang="en-US" sz="1250" dirty="0">
                           <a:solidFill>
-                            <a:srgbClr val="1F2328"/>
+                            <a:srgbClr val="373435"/>
                           </a:solidFill>
                           <a:latin typeface="Calibri" pitchFamily="34" charset="0"/>
                           <a:ea typeface="Calibri" pitchFamily="34" charset="-122"/>
@@ -14757,7 +14757,7 @@
                       <a:tailEnd type="none" w="med" len="med"/>
                     </a:lnB>
                     <a:solidFill>
-                      <a:srgbClr val="F1F2F3"/>
+                      <a:srgbClr val="EEF4F0"/>
                     </a:solidFill>
                   </a:tcPr>
                 </a:tc>
@@ -14774,7 +14774,7 @@
                       <a:r>
                         <a:rPr lang="en-US" sz="1250" b="1" dirty="0">
                           <a:solidFill>
-                            <a:srgbClr val="1F2328"/>
+                            <a:srgbClr val="373435"/>
                           </a:solidFill>
                           <a:latin typeface="Calibri" pitchFamily="34" charset="0"/>
                           <a:ea typeface="Calibri" pitchFamily="34" charset="-122"/>
@@ -14827,7 +14827,7 @@
                       <a:tailEnd type="none" w="med" len="med"/>
                     </a:lnB>
                     <a:solidFill>
-                      <a:srgbClr val="F1F2F3"/>
+                      <a:srgbClr val="EEF4F0"/>
                     </a:solidFill>
                   </a:tcPr>
                 </a:tc>
@@ -14842,7 +14842,7 @@
                       <a:r>
                         <a:rPr lang="en-US" sz="1250" dirty="0">
                           <a:solidFill>
-                            <a:srgbClr val="1F2328"/>
+                            <a:srgbClr val="373435"/>
                           </a:solidFill>
                           <a:latin typeface="Calibri" pitchFamily="34" charset="0"/>
                           <a:ea typeface="Calibri" pitchFamily="34" charset="-122"/>
@@ -14895,7 +14895,7 @@
                       <a:tailEnd type="none" w="med" len="med"/>
                     </a:lnB>
                     <a:solidFill>
-                      <a:srgbClr val="F1F2F3"/>
+                      <a:srgbClr val="EEF4F0"/>
                     </a:solidFill>
                   </a:tcPr>
                 </a:tc>
@@ -14910,7 +14910,7 @@
                       <a:r>
                         <a:rPr lang="en-US" sz="1250" dirty="0">
                           <a:solidFill>
-                            <a:srgbClr val="1F2328"/>
+                            <a:srgbClr val="373435"/>
                           </a:solidFill>
                           <a:latin typeface="Calibri" pitchFamily="34" charset="0"/>
                           <a:ea typeface="Calibri" pitchFamily="34" charset="-122"/>
@@ -14963,7 +14963,7 @@
                       <a:tailEnd type="none" w="med" len="med"/>
                     </a:lnB>
                     <a:solidFill>
-                      <a:srgbClr val="F1F2F3"/>
+                      <a:srgbClr val="EEF4F0"/>
                     </a:solidFill>
                   </a:tcPr>
                 </a:tc>
@@ -14980,7 +14980,7 @@
                       <a:r>
                         <a:rPr lang="en-US" sz="1250" b="1" dirty="0">
                           <a:solidFill>
-                            <a:srgbClr val="1F2328"/>
+                            <a:srgbClr val="373435"/>
                           </a:solidFill>
                           <a:latin typeface="Calibri" pitchFamily="34" charset="0"/>
                           <a:ea typeface="Calibri" pitchFamily="34" charset="-122"/>
@@ -15033,7 +15033,7 @@
                       <a:tailEnd type="none" w="med" len="med"/>
                     </a:lnB>
                     <a:solidFill>
-                      <a:srgbClr val="F1F2F3"/>
+                      <a:srgbClr val="EEF4F0"/>
                     </a:solidFill>
                   </a:tcPr>
                 </a:tc>
@@ -15048,7 +15048,7 @@
                       <a:r>
                         <a:rPr lang="en-US" sz="1250" dirty="0">
                           <a:solidFill>
-                            <a:srgbClr val="1F2328"/>
+                            <a:srgbClr val="373435"/>
                           </a:solidFill>
                           <a:latin typeface="Calibri" pitchFamily="34" charset="0"/>
                           <a:ea typeface="Calibri" pitchFamily="34" charset="-122"/>
@@ -15101,7 +15101,7 @@
                       <a:tailEnd type="none" w="med" len="med"/>
                     </a:lnB>
                     <a:solidFill>
-                      <a:srgbClr val="F1F2F3"/>
+                      <a:srgbClr val="EEF4F0"/>
                     </a:solidFill>
                   </a:tcPr>
                 </a:tc>
@@ -15116,7 +15116,7 @@
                       <a:r>
                         <a:rPr lang="en-US" sz="1250" dirty="0">
                           <a:solidFill>
-                            <a:srgbClr val="1F2328"/>
+                            <a:srgbClr val="373435"/>
                           </a:solidFill>
                           <a:latin typeface="Calibri" pitchFamily="34" charset="0"/>
                           <a:ea typeface="Calibri" pitchFamily="34" charset="-122"/>
@@ -15169,7 +15169,7 @@
                       <a:tailEnd type="none" w="med" len="med"/>
                     </a:lnB>
                     <a:solidFill>
-                      <a:srgbClr val="F1F2F3"/>
+                      <a:srgbClr val="EEF4F0"/>
                     </a:solidFill>
                   </a:tcPr>
                 </a:tc>
@@ -15777,7 +15777,7 @@
                       <a:tailEnd type="none" w="med" len="med"/>
                     </a:lnB>
                     <a:solidFill>
-                      <a:srgbClr val="8C2F39"/>
+                      <a:srgbClr val="00703C"/>
                     </a:solidFill>
                   </a:tcPr>
                 </a:tc>
@@ -15850,7 +15850,7 @@
                       <a:tailEnd type="none" w="med" len="med"/>
                     </a:lnB>
                     <a:solidFill>
-                      <a:srgbClr val="6B7076"/>
+                      <a:srgbClr val="6E6B6C"/>
                     </a:solidFill>
                   </a:tcPr>
                 </a:tc>
@@ -15865,7 +15865,7 @@
                       <a:r>
                         <a:rPr lang="en-US" sz="1200" dirty="0">
                           <a:solidFill>
-                            <a:srgbClr val="1F2328"/>
+                            <a:srgbClr val="373435"/>
                           </a:solidFill>
                           <a:latin typeface="Calibri" pitchFamily="34" charset="0"/>
                           <a:ea typeface="Calibri" pitchFamily="34" charset="-122"/>
@@ -15918,7 +15918,7 @@
                       <a:tailEnd type="none" w="med" len="med"/>
                     </a:lnB>
                     <a:solidFill>
-                      <a:srgbClr val="F1F2F3"/>
+                      <a:srgbClr val="EEF4F0"/>
                     </a:solidFill>
                   </a:tcPr>
                 </a:tc>
@@ -15988,7 +15988,7 @@
                       <a:tailEnd type="none" w="med" len="med"/>
                     </a:lnB>
                     <a:solidFill>
-                      <a:srgbClr val="6B7076"/>
+                      <a:srgbClr val="6E6B6C"/>
                     </a:solidFill>
                   </a:tcPr>
                 </a:tc>
@@ -16003,7 +16003,7 @@
                       <a:r>
                         <a:rPr lang="en-US" sz="1200" dirty="0">
                           <a:solidFill>
-                            <a:srgbClr val="1F2328"/>
+                            <a:srgbClr val="373435"/>
                           </a:solidFill>
                           <a:latin typeface="Calibri" pitchFamily="34" charset="0"/>
                           <a:ea typeface="Calibri" pitchFamily="34" charset="-122"/>
@@ -16056,7 +16056,7 @@
                       <a:tailEnd type="none" w="med" len="med"/>
                     </a:lnB>
                     <a:solidFill>
-                      <a:srgbClr val="F1F2F3"/>
+                      <a:srgbClr val="EEF4F0"/>
                     </a:solidFill>
                   </a:tcPr>
                 </a:tc>
@@ -16126,7 +16126,7 @@
                       <a:tailEnd type="none" w="med" len="med"/>
                     </a:lnB>
                     <a:solidFill>
-                      <a:srgbClr val="6B7076"/>
+                      <a:srgbClr val="6E6B6C"/>
                     </a:solidFill>
                   </a:tcPr>
                 </a:tc>
@@ -16141,7 +16141,7 @@
                       <a:r>
                         <a:rPr lang="en-US" sz="1200" dirty="0">
                           <a:solidFill>
-                            <a:srgbClr val="1F2328"/>
+                            <a:srgbClr val="373435"/>
                           </a:solidFill>
                           <a:latin typeface="Calibri" pitchFamily="34" charset="0"/>
                           <a:ea typeface="Calibri" pitchFamily="34" charset="-122"/>
@@ -16194,7 +16194,7 @@
                       <a:tailEnd type="none" w="med" len="med"/>
                     </a:lnB>
                     <a:solidFill>
-                      <a:srgbClr val="F1F2F3"/>
+                      <a:srgbClr val="EEF4F0"/>
                     </a:solidFill>
                   </a:tcPr>
                 </a:tc>
@@ -16264,7 +16264,7 @@
                       <a:tailEnd type="none" w="med" len="med"/>
                     </a:lnB>
                     <a:solidFill>
-                      <a:srgbClr val="6B7076"/>
+                      <a:srgbClr val="6E6B6C"/>
                     </a:solidFill>
                   </a:tcPr>
                 </a:tc>
@@ -16279,7 +16279,7 @@
                       <a:r>
                         <a:rPr lang="en-US" sz="1200" dirty="0">
                           <a:solidFill>
-                            <a:srgbClr val="1F2328"/>
+                            <a:srgbClr val="373435"/>
                           </a:solidFill>
                           <a:latin typeface="Calibri" pitchFamily="34" charset="0"/>
                           <a:ea typeface="Calibri" pitchFamily="34" charset="-122"/>
@@ -16332,7 +16332,7 @@
                       <a:tailEnd type="none" w="med" len="med"/>
                     </a:lnB>
                     <a:solidFill>
-                      <a:srgbClr val="F1F2F3"/>
+                      <a:srgbClr val="EEF4F0"/>
                     </a:solidFill>
                   </a:tcPr>
                 </a:tc>
@@ -16402,7 +16402,7 @@
                       <a:tailEnd type="none" w="med" len="med"/>
                     </a:lnB>
                     <a:solidFill>
-                      <a:srgbClr val="6B7076"/>
+                      <a:srgbClr val="6E6B6C"/>
                     </a:solidFill>
                   </a:tcPr>
                 </a:tc>
@@ -16417,7 +16417,7 @@
                       <a:r>
                         <a:rPr lang="en-US" sz="1200" dirty="0">
                           <a:solidFill>
-                            <a:srgbClr val="1F2328"/>
+                            <a:srgbClr val="373435"/>
                           </a:solidFill>
                           <a:latin typeface="Calibri" pitchFamily="34" charset="0"/>
                           <a:ea typeface="Calibri" pitchFamily="34" charset="-122"/>
@@ -16470,7 +16470,7 @@
                       <a:tailEnd type="none" w="med" len="med"/>
                     </a:lnB>
                     <a:solidFill>
-                      <a:srgbClr val="F1F2F3"/>
+                      <a:srgbClr val="EEF4F0"/>
                     </a:solidFill>
                   </a:tcPr>
                 </a:tc>
@@ -16540,7 +16540,7 @@
                       <a:tailEnd type="none" w="med" len="med"/>
                     </a:lnB>
                     <a:solidFill>
-                      <a:srgbClr val="6B7076"/>
+                      <a:srgbClr val="6E6B6C"/>
                     </a:solidFill>
                   </a:tcPr>
                 </a:tc>
@@ -16555,7 +16555,7 @@
                       <a:r>
                         <a:rPr lang="en-US" sz="1200" dirty="0">
                           <a:solidFill>
-                            <a:srgbClr val="1F2328"/>
+                            <a:srgbClr val="373435"/>
                           </a:solidFill>
                           <a:latin typeface="Calibri" pitchFamily="34" charset="0"/>
                           <a:ea typeface="Calibri" pitchFamily="34" charset="-122"/>
@@ -16608,7 +16608,7 @@
                       <a:tailEnd type="none" w="med" len="med"/>
                     </a:lnB>
                     <a:solidFill>
-                      <a:srgbClr val="F1F2F3"/>
+                      <a:srgbClr val="EEF4F0"/>
                     </a:solidFill>
                   </a:tcPr>
                 </a:tc>
@@ -16678,7 +16678,7 @@
                       <a:tailEnd type="none" w="med" len="med"/>
                     </a:lnB>
                     <a:solidFill>
-                      <a:srgbClr val="6B7076"/>
+                      <a:srgbClr val="6E6B6C"/>
                     </a:solidFill>
                   </a:tcPr>
                 </a:tc>
@@ -16693,7 +16693,7 @@
                       <a:r>
                         <a:rPr lang="en-US" sz="1200" dirty="0">
                           <a:solidFill>
-                            <a:srgbClr val="1F2328"/>
+                            <a:srgbClr val="373435"/>
                           </a:solidFill>
                           <a:latin typeface="Calibri" pitchFamily="34" charset="0"/>
                           <a:ea typeface="Calibri" pitchFamily="34" charset="-122"/>
@@ -16746,7 +16746,7 @@
                       <a:tailEnd type="none" w="med" len="med"/>
                     </a:lnB>
                     <a:solidFill>
-                      <a:srgbClr val="F1F2F3"/>
+                      <a:srgbClr val="EEF4F0"/>
                     </a:solidFill>
                   </a:tcPr>
                 </a:tc>
@@ -16816,7 +16816,7 @@
                       <a:tailEnd type="none" w="med" len="med"/>
                     </a:lnB>
                     <a:solidFill>
-                      <a:srgbClr val="6B7076"/>
+                      <a:srgbClr val="6E6B6C"/>
                     </a:solidFill>
                   </a:tcPr>
                 </a:tc>
@@ -16831,7 +16831,7 @@
                       <a:r>
                         <a:rPr lang="en-US" sz="1200" dirty="0">
                           <a:solidFill>
-                            <a:srgbClr val="1F2328"/>
+                            <a:srgbClr val="373435"/>
                           </a:solidFill>
                           <a:latin typeface="Calibri" pitchFamily="34" charset="0"/>
                           <a:ea typeface="Calibri" pitchFamily="34" charset="-122"/>
@@ -16884,7 +16884,7 @@
                       <a:tailEnd type="none" w="med" len="med"/>
                     </a:lnB>
                     <a:solidFill>
-                      <a:srgbClr val="F1F2F3"/>
+                      <a:srgbClr val="EEF4F0"/>
                     </a:solidFill>
                   </a:tcPr>
                 </a:tc>
@@ -16954,7 +16954,7 @@
                       <a:tailEnd type="none" w="med" len="med"/>
                     </a:lnB>
                     <a:solidFill>
-                      <a:srgbClr val="6B7076"/>
+                      <a:srgbClr val="6E6B6C"/>
                     </a:solidFill>
                   </a:tcPr>
                 </a:tc>
@@ -16969,7 +16969,7 @@
                       <a:r>
                         <a:rPr lang="en-US" sz="1200" dirty="0">
                           <a:solidFill>
-                            <a:srgbClr val="1F2328"/>
+                            <a:srgbClr val="373435"/>
                           </a:solidFill>
                           <a:latin typeface="Calibri" pitchFamily="34" charset="0"/>
                           <a:ea typeface="Calibri" pitchFamily="34" charset="-122"/>
@@ -17022,7 +17022,7 @@
                       <a:tailEnd type="none" w="med" len="med"/>
                     </a:lnB>
                     <a:solidFill>
-                      <a:srgbClr val="F1F2F3"/>
+                      <a:srgbClr val="EEF4F0"/>
                     </a:solidFill>
                   </a:tcPr>
                 </a:tc>
@@ -17092,7 +17092,7 @@
                       <a:tailEnd type="none" w="med" len="med"/>
                     </a:lnB>
                     <a:solidFill>
-                      <a:srgbClr val="6B7076"/>
+                      <a:srgbClr val="6E6B6C"/>
                     </a:solidFill>
                   </a:tcPr>
                 </a:tc>
@@ -17107,7 +17107,7 @@
                       <a:r>
                         <a:rPr lang="en-US" sz="1200" dirty="0">
                           <a:solidFill>
-                            <a:srgbClr val="1F2328"/>
+                            <a:srgbClr val="373435"/>
                           </a:solidFill>
                           <a:latin typeface="Calibri" pitchFamily="34" charset="0"/>
                           <a:ea typeface="Calibri" pitchFamily="34" charset="-122"/>
@@ -17160,7 +17160,7 @@
                       <a:tailEnd type="none" w="med" len="med"/>
                     </a:lnB>
                     <a:solidFill>
-                      <a:srgbClr val="F1F2F3"/>
+                      <a:srgbClr val="EEF4F0"/>
                     </a:solidFill>
                   </a:tcPr>
                 </a:tc>
@@ -17230,7 +17230,7 @@
                       <a:tailEnd type="none" w="med" len="med"/>
                     </a:lnB>
                     <a:solidFill>
-                      <a:srgbClr val="6B7076"/>
+                      <a:srgbClr val="6E6B6C"/>
                     </a:solidFill>
                   </a:tcPr>
                 </a:tc>
@@ -17245,7 +17245,7 @@
                       <a:r>
                         <a:rPr lang="en-US" sz="1200" dirty="0">
                           <a:solidFill>
-                            <a:srgbClr val="1F2328"/>
+                            <a:srgbClr val="373435"/>
                           </a:solidFill>
                           <a:latin typeface="Calibri" pitchFamily="34" charset="0"/>
                           <a:ea typeface="Calibri" pitchFamily="34" charset="-122"/>
@@ -17298,7 +17298,7 @@
                       <a:tailEnd type="none" w="med" len="med"/>
                     </a:lnB>
                     <a:solidFill>
-                      <a:srgbClr val="F1F2F3"/>
+                      <a:srgbClr val="EEF4F0"/>
                     </a:solidFill>
                   </a:tcPr>
                 </a:tc>
@@ -17368,7 +17368,7 @@
                       <a:tailEnd type="none" w="med" len="med"/>
                     </a:lnB>
                     <a:solidFill>
-                      <a:srgbClr val="6B7076"/>
+                      <a:srgbClr val="6E6B6C"/>
                     </a:solidFill>
                   </a:tcPr>
                 </a:tc>
@@ -17383,7 +17383,7 @@
                       <a:r>
                         <a:rPr lang="en-US" sz="1200" dirty="0">
                           <a:solidFill>
-                            <a:srgbClr val="1F2328"/>
+                            <a:srgbClr val="373435"/>
                           </a:solidFill>
                           <a:latin typeface="Calibri" pitchFamily="34" charset="0"/>
                           <a:ea typeface="Calibri" pitchFamily="34" charset="-122"/>
@@ -17436,7 +17436,7 @@
                       <a:tailEnd type="none" w="med" len="med"/>
                     </a:lnB>
                     <a:solidFill>
-                      <a:srgbClr val="F1F2F3"/>
+                      <a:srgbClr val="EEF4F0"/>
                     </a:solidFill>
                   </a:tcPr>
                 </a:tc>
@@ -17506,7 +17506,7 @@
                       <a:tailEnd type="none" w="med" len="med"/>
                     </a:lnB>
                     <a:solidFill>
-                      <a:srgbClr val="6B7076"/>
+                      <a:srgbClr val="6E6B6C"/>
                     </a:solidFill>
                   </a:tcPr>
                 </a:tc>
@@ -17521,7 +17521,7 @@
                       <a:r>
                         <a:rPr lang="en-US" sz="1200" dirty="0">
                           <a:solidFill>
-                            <a:srgbClr val="1F2328"/>
+                            <a:srgbClr val="373435"/>
                           </a:solidFill>
                           <a:latin typeface="Calibri" pitchFamily="34" charset="0"/>
                           <a:ea typeface="Calibri" pitchFamily="34" charset="-122"/>
@@ -17574,7 +17574,7 @@
                       <a:tailEnd type="none" w="med" len="med"/>
                     </a:lnB>
                     <a:solidFill>
-                      <a:srgbClr val="F1F2F3"/>
+                      <a:srgbClr val="EEF4F0"/>
                     </a:solidFill>
                   </a:tcPr>
                 </a:tc>
@@ -17644,7 +17644,7 @@
                       <a:tailEnd type="none" w="med" len="med"/>
                     </a:lnB>
                     <a:solidFill>
-                      <a:srgbClr val="6B7076"/>
+                      <a:srgbClr val="6E6B6C"/>
                     </a:solidFill>
                   </a:tcPr>
                 </a:tc>
@@ -17659,7 +17659,7 @@
                       <a:r>
                         <a:rPr lang="en-US" sz="1200" dirty="0">
                           <a:solidFill>
-                            <a:srgbClr val="1F2328"/>
+                            <a:srgbClr val="373435"/>
                           </a:solidFill>
                           <a:latin typeface="Calibri" pitchFamily="34" charset="0"/>
                           <a:ea typeface="Calibri" pitchFamily="34" charset="-122"/>
@@ -17712,7 +17712,7 @@
                       <a:tailEnd type="none" w="med" len="med"/>
                     </a:lnB>
                     <a:solidFill>
-                      <a:srgbClr val="F1F2F3"/>
+                      <a:srgbClr val="EEF4F0"/>
                     </a:solidFill>
                   </a:tcPr>
                 </a:tc>
@@ -17807,7 +17807,7 @@
           </a:prstGeom>
           <a:ln w="9525">
             <a:solidFill>
-              <a:schemeClr val="accent4"/>
+              <a:schemeClr val="accent3"/>
             </a:solidFill>
             <a:prstDash val="solid"/>
           </a:ln>
@@ -17829,7 +17829,7 @@
           </a:prstGeom>
           <a:ln w="9525">
             <a:solidFill>
-              <a:schemeClr val="accent4"/>
+              <a:schemeClr val="accent3"/>
             </a:solidFill>
             <a:prstDash val="solid"/>
           </a:ln>
@@ -17850,7 +17850,7 @@
             <a:avLst/>
           </a:prstGeom>
           <a:solidFill>
-            <a:schemeClr val="accent1"/>
+            <a:schemeClr val="bg1"/>
           </a:solidFill>
           <a:ln/>
         </p:spPr>
@@ -17884,7 +17884,7 @@
             <a:r>
               <a:rPr lang="en-US" sz="4800" b="1" dirty="0">
                 <a:solidFill>
-                  <a:schemeClr val="bg1"/>
+                  <a:schemeClr val="tx2"/>
                 </a:solidFill>
               </a:rPr>
               <a:t>2</a:t>
@@ -21458,47 +21458,47 @@
 </file>
 
 <file path=ppt/theme/theme1.xml><?xml version="1.0" encoding="utf-8"?>
-<a:theme xmlns:a="http://schemas.openxmlformats.org/drawingml/2006/main" name="Pontos de atencao">
+<a:theme xmlns:a="http://schemas.openxmlformats.org/drawingml/2006/main" name="Pontos de atencao verde">
   <a:themeElements>
-    <a:clrScheme name="Pontos de atencao">
+    <a:clrScheme name="Pontos de atencao verde">
       <a:dk1>
-        <a:srgbClr val="1F2328"/>
+        <a:srgbClr val="373435"/>
       </a:dk1>
       <a:lt1>
         <a:srgbClr val="FFFFFF"/>
       </a:lt1>
       <a:dk2>
-        <a:srgbClr val="2E3236"/>
+        <a:srgbClr val="006237"/>
       </a:dk2>
       <a:lt2>
-        <a:srgbClr val="F1F2F3"/>
+        <a:srgbClr val="EEF4F0"/>
       </a:lt2>
       <a:accent1>
-        <a:srgbClr val="8C2F39"/>
+        <a:srgbClr val="00703C"/>
       </a:accent1>
       <a:accent2>
-        <a:srgbClr val="5E1D25"/>
+        <a:srgbClr val="006237"/>
       </a:accent2>
       <a:accent3>
-        <a:srgbClr val="D9B8BC"/>
+        <a:srgbClr val="B9DCC6"/>
       </a:accent3>
       <a:accent4>
-        <a:srgbClr val="6B7076"/>
+        <a:srgbClr val="6E6B6C"/>
       </a:accent4>
       <a:accent5>
-        <a:srgbClr val="D6D9DC"/>
+        <a:srgbClr val="D3DDD7"/>
       </a:accent5>
       <a:accent6>
-        <a:srgbClr val="A8646C"/>
+        <a:srgbClr val="56A8AC"/>
       </a:accent6>
       <a:hlink>
-        <a:srgbClr val="8C2F39"/>
+        <a:srgbClr val="00703C"/>
       </a:hlink>
       <a:folHlink>
-        <a:srgbClr val="5E1D25"/>
+        <a:srgbClr val="006237"/>
       </a:folHlink>
     </a:clrScheme>
-    <a:fontScheme name="Pontos de atencao">
+    <a:fontScheme name="Pontos de atencao verde">
       <a:majorFont>
         <a:latin typeface="Calibri"/>
         <a:ea typeface=""/>

</xml_diff>